<commit_message>
Fix JSO slide: remove definition, steps-only layout, no green bullet circles
Co-Authored-By: Claude Sonnet 4.6 <noreply@anthropic.com>
Claude-Session: https://claude.ai/code/session_01Mg3T3KyTNr8vyUakWmpgWc
</commit_message>
<xml_diff>
--- a/safety_officer_guide.pptx
+++ b/safety_officer_guide.pptx
@@ -9064,341 +9064,184 @@
       </p:sp>
       <p:sp>
         <p:nvSpPr>
-          <p:cNvPr id="3" name="Text 1"/>
-          <p:cNvSpPr/>
-          <p:nvPr/>
-        </p:nvSpPr>
-        <p:spPr>
-          <a:xfrm>
-            <a:off x="411480" y="182880"/>
-            <a:ext cx="8321040" cy="594360"/>
-          </a:xfrm>
-          <a:prstGeom prst="rect">
-            <a:avLst/>
-          </a:prstGeom>
-          <a:noFill/>
-          <a:ln/>
-        </p:spPr>
-        <p:txBody>
-          <a:bodyPr wrap="square" lIns="0" tIns="0" rIns="0" bIns="0" rtlCol="0" anchor="ctr"/>
-          <a:lstStyle/>
-          <a:p>
-            <a:pPr indent="0" marL="0">
+          <p:cNvPr id="3" name="Shape 1"/>
+          <p:cNvSpPr/>
+          <p:nvPr/>
+        </p:nvSpPr>
+        <p:spPr>
+          <a:xfrm>
+            <a:off x="0" y="0"/>
+            <a:ext cx="3200400" cy="5143500"/>
+          </a:xfrm>
+          <a:prstGeom prst="rect">
+            <a:avLst/>
+          </a:prstGeom>
+          <a:solidFill>
+            <a:srgbClr val="1B4332"/>
+          </a:solidFill>
+          <a:ln/>
+        </p:spPr>
+      </p:sp>
+      <p:sp>
+        <p:nvSpPr>
+          <p:cNvPr id="4" name="Text 2"/>
+          <p:cNvSpPr/>
+          <p:nvPr/>
+        </p:nvSpPr>
+        <p:spPr>
+          <a:xfrm>
+            <a:off x="182880" y="320040"/>
+            <a:ext cx="2834640" cy="640080"/>
+          </a:xfrm>
+          <a:prstGeom prst="rect">
+            <a:avLst/>
+          </a:prstGeom>
+          <a:noFill/>
+          <a:ln/>
+        </p:spPr>
+        <p:txBody>
+          <a:bodyPr wrap="square" lIns="0" tIns="0" rIns="0" bIns="0" rtlCol="0" anchor="ctr"/>
+          <a:lstStyle/>
+          <a:p>
+            <a:pPr algn="ctr" indent="0" marL="0">
+              <a:buNone/>
+            </a:pPr>
+            <a:r>
+              <a:rPr lang="en-US" sz="3600" dirty="0">
+                <a:solidFill>
+                  <a:srgbClr val="000000"/>
+                </a:solidFill>
+              </a:rPr>
+              <a:t>📄</a:t>
+            </a:r>
+            <a:endParaRPr lang="en-US" sz="3600" dirty="0"/>
+          </a:p>
+        </p:txBody>
+      </p:sp>
+      <p:sp>
+        <p:nvSpPr>
+          <p:cNvPr id="5" name="Text 3"/>
+          <p:cNvSpPr/>
+          <p:nvPr/>
+        </p:nvSpPr>
+        <p:spPr>
+          <a:xfrm>
+            <a:off x="182880" y="1005840"/>
+            <a:ext cx="2834640" cy="822960"/>
+          </a:xfrm>
+          <a:prstGeom prst="rect">
+            <a:avLst/>
+          </a:prstGeom>
+          <a:noFill/>
+          <a:ln/>
+        </p:spPr>
+        <p:txBody>
+          <a:bodyPr wrap="square" lIns="0" tIns="0" rIns="0" bIns="0" rtlCol="0" anchor="ctr"/>
+          <a:lstStyle/>
+          <a:p>
+            <a:pPr algn="ctr" indent="0" marL="0">
               <a:buNone/>
             </a:pPr>
             <a:r>
               <a:rPr lang="en-US" sz="2600" b="1" dirty="0">
                 <a:solidFill>
-                  <a:srgbClr val="1B4332"/>
+                  <a:srgbClr val="FFFFFF"/>
                 </a:solidFill>
                 <a:latin typeface="Cambria" pitchFamily="34" charset="0"/>
                 <a:ea typeface="Cambria" pitchFamily="34" charset="-122"/>
                 <a:cs typeface="Cambria" pitchFamily="34" charset="-120"/>
               </a:rPr>
-              <a:t>📄  JSO Closure</a:t>
+              <a:t>JSO</a:t>
             </a:r>
             <a:endParaRPr lang="en-US" sz="2600" dirty="0"/>
           </a:p>
-        </p:txBody>
-      </p:sp>
-      <p:sp>
-        <p:nvSpPr>
-          <p:cNvPr id="4" name="Text 2"/>
-          <p:cNvSpPr/>
-          <p:nvPr/>
-        </p:nvSpPr>
-        <p:spPr>
-          <a:xfrm>
-            <a:off x="411480" y="621792"/>
-            <a:ext cx="8321040" cy="347472"/>
-          </a:xfrm>
-          <a:prstGeom prst="rect">
-            <a:avLst/>
-          </a:prstGeom>
-          <a:noFill/>
-          <a:ln/>
-        </p:spPr>
-        <p:txBody>
-          <a:bodyPr wrap="square" lIns="0" tIns="0" rIns="0" bIns="0" rtlCol="0" anchor="t"/>
-          <a:lstStyle/>
-          <a:p>
-            <a:pPr indent="0" marL="0">
-              <a:buNone/>
-            </a:pPr>
-            <a:r>
-              <a:rPr lang="en-US" sz="1200" dirty="0">
-                <a:solidFill>
-                  <a:srgbClr val="334155"/>
-                </a:solidFill>
-                <a:latin typeface="Calibri" pitchFamily="34" charset="0"/>
-                <a:ea typeface="Calibri" pitchFamily="34" charset="-122"/>
-                <a:cs typeface="Calibri" pitchFamily="34" charset="-120"/>
-              </a:rPr>
-              <a:t>A JSO (Job Safety Observation) closure records that a safety issue identified during a JSO has been resolved.</a:t>
-            </a:r>
-            <a:endParaRPr lang="en-US" sz="1200" dirty="0"/>
-          </a:p>
-        </p:txBody>
-      </p:sp>
-      <p:sp>
-        <p:nvSpPr>
-          <p:cNvPr id="5" name="Shape 3"/>
-          <p:cNvSpPr/>
-          <p:nvPr/>
-        </p:nvSpPr>
-        <p:spPr>
-          <a:xfrm>
-            <a:off x="411480" y="1051560"/>
-            <a:ext cx="3931920" cy="3931920"/>
-          </a:xfrm>
-          <a:prstGeom prst="rect">
-            <a:avLst>
-              <a:gd name="adj" fmla="val 1860"/>
-            </a:avLst>
-          </a:prstGeom>
-          <a:solidFill>
-            <a:srgbClr val="FFFFFF"/>
-          </a:solidFill>
-          <a:ln w="12700">
-            <a:solidFill>
-              <a:srgbClr val="E2E8F0"/>
-            </a:solidFill>
-            <a:prstDash val="solid"/>
-          </a:ln>
-        </p:spPr>
-      </p:sp>
-      <p:sp>
-        <p:nvSpPr>
-          <p:cNvPr id="6" name="Text 4"/>
-          <p:cNvSpPr/>
-          <p:nvPr/>
-        </p:nvSpPr>
-        <p:spPr>
-          <a:xfrm>
-            <a:off x="548640" y="1143000"/>
-            <a:ext cx="3657600" cy="320040"/>
-          </a:xfrm>
-          <a:prstGeom prst="rect">
-            <a:avLst/>
-          </a:prstGeom>
-          <a:noFill/>
-          <a:ln/>
-        </p:spPr>
-        <p:txBody>
-          <a:bodyPr wrap="square" lIns="0" tIns="0" rIns="0" bIns="0" rtlCol="0" anchor="ctr"/>
-          <a:lstStyle/>
-          <a:p>
-            <a:pPr indent="0" marL="0">
-              <a:buNone/>
-            </a:pPr>
-            <a:r>
-              <a:rPr lang="en-US" sz="1400" b="1" dirty="0">
-                <a:solidFill>
-                  <a:srgbClr val="16A34A"/>
+          <a:p>
+            <a:pPr algn="ctr" indent="0" marL="0">
+              <a:buNone/>
+            </a:pPr>
+            <a:r>
+              <a:rPr lang="en-US" sz="2600" b="1" dirty="0">
+                <a:solidFill>
+                  <a:srgbClr val="FFFFFF"/>
                 </a:solidFill>
                 <a:latin typeface="Cambria" pitchFamily="34" charset="0"/>
                 <a:ea typeface="Cambria" pitchFamily="34" charset="-122"/>
                 <a:cs typeface="Cambria" pitchFamily="34" charset="-120"/>
               </a:rPr>
-              <a:t>What is a JSO?</a:t>
-            </a:r>
-            <a:endParaRPr lang="en-US" sz="1400" dirty="0"/>
-          </a:p>
-        </p:txBody>
-      </p:sp>
-      <p:sp>
-        <p:nvSpPr>
-          <p:cNvPr id="7" name="Text 5"/>
-          <p:cNvSpPr/>
-          <p:nvPr/>
-        </p:nvSpPr>
-        <p:spPr>
-          <a:xfrm>
-            <a:off x="548640" y="1536192"/>
-            <a:ext cx="3657600" cy="3291840"/>
-          </a:xfrm>
-          <a:prstGeom prst="rect">
-            <a:avLst/>
-          </a:prstGeom>
-          <a:noFill/>
-          <a:ln/>
-        </p:spPr>
-        <p:txBody>
-          <a:bodyPr wrap="square" lIns="0" tIns="0" rIns="0" bIns="0" rtlCol="0" anchor="t"/>
-          <a:lstStyle/>
-          <a:p>
-            <a:pPr indent="0" marL="0">
+              <a:t>Closure</a:t>
+            </a:r>
+            <a:endParaRPr lang="en-US" sz="2600" dirty="0"/>
+          </a:p>
+        </p:txBody>
+      </p:sp>
+      <p:sp>
+        <p:nvSpPr>
+          <p:cNvPr id="6" name="Text 4"/>
+          <p:cNvSpPr/>
+          <p:nvPr/>
+        </p:nvSpPr>
+        <p:spPr>
+          <a:xfrm>
+            <a:off x="182880" y="1938528"/>
+            <a:ext cx="2834640" cy="822960"/>
+          </a:xfrm>
+          <a:prstGeom prst="rect">
+            <a:avLst/>
+          </a:prstGeom>
+          <a:noFill/>
+          <a:ln/>
+        </p:spPr>
+        <p:txBody>
+          <a:bodyPr wrap="square" lIns="0" tIns="0" rIns="0" bIns="0" rtlCol="0" anchor="ctr"/>
+          <a:lstStyle/>
+          <a:p>
+            <a:pPr algn="ctr" indent="0" marL="0">
               <a:buNone/>
             </a:pPr>
             <a:r>
               <a:rPr lang="en-US" sz="1100" dirty="0">
                 <a:solidFill>
-                  <a:srgbClr val="334155"/>
-                </a:solidFill>
-                <a:latin typeface="Calibri" pitchFamily="34" charset="0"/>
-                <a:ea typeface="Calibri" pitchFamily="34" charset="-122"/>
-                <a:cs typeface="Calibri" pitchFamily="34" charset="-120"/>
-              </a:rPr>
-              <a:t>A Job Safety Observation </a:t>
-            </a:r>
-            <a:pPr indent="0" marL="0">
-              <a:buNone/>
-            </a:pPr>
-            <a:r>
-              <a:rPr lang="en-US" sz="1100" b="1" dirty="0">
-                <a:solidFill>
-                  <a:srgbClr val="334155"/>
-                </a:solidFill>
-                <a:latin typeface="Calibri" pitchFamily="34" charset="0"/>
-                <a:ea typeface="Calibri" pitchFamily="34" charset="-122"/>
-                <a:cs typeface="Calibri" pitchFamily="34" charset="-120"/>
-              </a:rPr>
-              <a:t>(JSO)</a:t>
-            </a:r>
-            <a:pPr indent="0" marL="0">
+                  <a:srgbClr val="DCFCE7"/>
+                </a:solidFill>
+                <a:latin typeface="Calibri" pitchFamily="34" charset="0"/>
+                <a:ea typeface="Calibri" pitchFamily="34" charset="-122"/>
+                <a:cs typeface="Calibri" pitchFamily="34" charset="-120"/>
+              </a:rPr>
+              <a:t>Go to JSO in the top</a:t>
+            </a:r>
+            <a:endParaRPr lang="en-US" sz="1100" dirty="0"/>
+          </a:p>
+          <a:p>
+            <a:pPr algn="ctr" indent="0" marL="0">
               <a:buNone/>
             </a:pPr>
             <a:r>
               <a:rPr lang="en-US" sz="1100" dirty="0">
                 <a:solidFill>
-                  <a:srgbClr val="334155"/>
-                </a:solidFill>
-                <a:latin typeface="Calibri" pitchFamily="34" charset="0"/>
-                <a:ea typeface="Calibri" pitchFamily="34" charset="-122"/>
-                <a:cs typeface="Calibri" pitchFamily="34" charset="-120"/>
-              </a:rPr>
-              <a:t> is a formal inspection of a job task to identify and correct hazards before work begins.
-</a:t>
-            </a:r>
-            <a:pPr indent="0" marL="0">
-              <a:buNone/>
-            </a:pPr>
-            <a:r>
-              <a:rPr lang="en-US" sz="1100" b="1" dirty="0">
-                <a:solidFill>
-                  <a:srgbClr val="334155"/>
-                </a:solidFill>
-                <a:latin typeface="Calibri" pitchFamily="34" charset="0"/>
-                <a:ea typeface="Calibri" pitchFamily="34" charset="-122"/>
-                <a:cs typeface="Calibri" pitchFamily="34" charset="-120"/>
-              </a:rPr>
-              <a:t>The JSO Closure </a:t>
-            </a:r>
-            <a:pPr indent="0" marL="0">
+                  <a:srgbClr val="DCFCE7"/>
+                </a:solidFill>
+                <a:latin typeface="Calibri" pitchFamily="34" charset="0"/>
+                <a:ea typeface="Calibri" pitchFamily="34" charset="-122"/>
+                <a:cs typeface="Calibri" pitchFamily="34" charset="-120"/>
+              </a:rPr>
+              <a:t>menu — click</a:t>
+            </a:r>
+            <a:endParaRPr lang="en-US" sz="1100" dirty="0"/>
+          </a:p>
+          <a:p>
+            <a:pPr algn="ctr" indent="0" marL="0">
               <a:buNone/>
             </a:pPr>
             <a:r>
               <a:rPr lang="en-US" sz="1100" dirty="0">
                 <a:solidFill>
-                  <a:srgbClr val="334155"/>
-                </a:solidFill>
-                <a:latin typeface="Calibri" pitchFamily="34" charset="0"/>
-                <a:ea typeface="Calibri" pitchFamily="34" charset="-122"/>
-                <a:cs typeface="Calibri" pitchFamily="34" charset="-120"/>
-              </a:rPr>
-              <a:t>in this system records that:
-</a:t>
-            </a:r>
-            <a:pPr indent="0" marL="0">
-              <a:buNone/>
-            </a:pPr>
-            <a:r>
-              <a:rPr lang="en-US" sz="1100" b="1" dirty="0">
-                <a:solidFill>
-                  <a:srgbClr val="16A34A"/>
-                </a:solidFill>
-                <a:latin typeface="Calibri" pitchFamily="34" charset="0"/>
-                <a:ea typeface="Calibri" pitchFamily="34" charset="-122"/>
-                <a:cs typeface="Calibri" pitchFamily="34" charset="-120"/>
-              </a:rPr>
-              <a:t>• </a:t>
-            </a:r>
-            <a:pPr indent="0" marL="0">
-              <a:buNone/>
-            </a:pPr>
-            <a:r>
-              <a:rPr lang="en-US" sz="1100" dirty="0">
-                <a:solidFill>
-                  <a:srgbClr val="334155"/>
-                </a:solidFill>
-                <a:latin typeface="Calibri" pitchFamily="34" charset="0"/>
-                <a:ea typeface="Calibri" pitchFamily="34" charset="-122"/>
-                <a:cs typeface="Calibri" pitchFamily="34" charset="-120"/>
-              </a:rPr>
-              <a:t>A JSO was conducted
-</a:t>
-            </a:r>
-            <a:pPr indent="0" marL="0">
-              <a:buNone/>
-            </a:pPr>
-            <a:r>
-              <a:rPr lang="en-US" sz="1100" b="1" dirty="0">
-                <a:solidFill>
-                  <a:srgbClr val="16A34A"/>
-                </a:solidFill>
-                <a:latin typeface="Calibri" pitchFamily="34" charset="0"/>
-                <a:ea typeface="Calibri" pitchFamily="34" charset="-122"/>
-                <a:cs typeface="Calibri" pitchFamily="34" charset="-120"/>
-              </a:rPr>
-              <a:t>• </a:t>
-            </a:r>
-            <a:pPr indent="0" marL="0">
-              <a:buNone/>
-            </a:pPr>
-            <a:r>
-              <a:rPr lang="en-US" sz="1100" dirty="0">
-                <a:solidFill>
-                  <a:srgbClr val="334155"/>
-                </a:solidFill>
-                <a:latin typeface="Calibri" pitchFamily="34" charset="0"/>
-                <a:ea typeface="Calibri" pitchFamily="34" charset="-122"/>
-                <a:cs typeface="Calibri" pitchFamily="34" charset="-120"/>
-              </a:rPr>
-              <a:t>Hazards were identified
-</a:t>
-            </a:r>
-            <a:pPr indent="0" marL="0">
-              <a:buNone/>
-            </a:pPr>
-            <a:r>
-              <a:rPr lang="en-US" sz="1100" b="1" dirty="0">
-                <a:solidFill>
-                  <a:srgbClr val="16A34A"/>
-                </a:solidFill>
-                <a:latin typeface="Calibri" pitchFamily="34" charset="0"/>
-                <a:ea typeface="Calibri" pitchFamily="34" charset="-122"/>
-                <a:cs typeface="Calibri" pitchFamily="34" charset="-120"/>
-              </a:rPr>
-              <a:t>• </a:t>
-            </a:r>
-            <a:pPr indent="0" marL="0">
-              <a:buNone/>
-            </a:pPr>
-            <a:r>
-              <a:rPr lang="en-US" sz="1100" dirty="0">
-                <a:solidFill>
-                  <a:srgbClr val="334155"/>
-                </a:solidFill>
-                <a:latin typeface="Calibri" pitchFamily="34" charset="0"/>
-                <a:ea typeface="Calibri" pitchFamily="34" charset="-122"/>
-                <a:cs typeface="Calibri" pitchFamily="34" charset="-120"/>
-              </a:rPr>
-              <a:t>Actions were taken and the issue is now CLOSED
-</a:t>
-            </a:r>
-            <a:pPr indent="0" marL="0">
-              <a:buNone/>
-            </a:pPr>
-            <a:r>
-              <a:rPr lang="en-US" sz="1100" i="1" dirty="0">
-                <a:solidFill>
-                  <a:srgbClr val="64748B"/>
-                </a:solidFill>
-                <a:latin typeface="Calibri" pitchFamily="34" charset="0"/>
-                <a:ea typeface="Calibri" pitchFamily="34" charset="-122"/>
-                <a:cs typeface="Calibri" pitchFamily="34" charset="-120"/>
-              </a:rPr>
-              <a:t>Each record includes a unique JSO number for traceability.</a:t>
+                  <a:srgbClr val="DCFCE7"/>
+                </a:solidFill>
+                <a:latin typeface="Calibri" pitchFamily="34" charset="0"/>
+                <a:ea typeface="Calibri" pitchFamily="34" charset="-122"/>
+                <a:cs typeface="Calibri" pitchFamily="34" charset="-120"/>
+              </a:rPr>
+              <a:t>"+ New JSO Closure"</a:t>
             </a:r>
             <a:endParaRPr lang="en-US" sz="1100" dirty="0"/>
           </a:p>
@@ -9406,30 +9249,138 @@
       </p:sp>
       <p:sp>
         <p:nvSpPr>
-          <p:cNvPr id="8" name="Shape 6"/>
-          <p:cNvSpPr/>
-          <p:nvPr/>
-        </p:nvSpPr>
-        <p:spPr>
-          <a:xfrm>
-            <a:off x="4663440" y="1051560"/>
-            <a:ext cx="4069080" cy="3931920"/>
+          <p:cNvPr id="7" name="Shape 5"/>
+          <p:cNvSpPr/>
+          <p:nvPr/>
+        </p:nvSpPr>
+        <p:spPr>
+          <a:xfrm>
+            <a:off x="182880" y="2926080"/>
+            <a:ext cx="2834640" cy="2011680"/>
           </a:xfrm>
           <a:prstGeom prst="rect">
             <a:avLst>
-              <a:gd name="adj" fmla="val 1860"/>
+              <a:gd name="adj" fmla="val 2727"/>
             </a:avLst>
           </a:prstGeom>
           <a:solidFill>
-            <a:srgbClr val="DCFCE7"/>
+            <a:srgbClr val="F59E0B"/>
           </a:solidFill>
-          <a:ln w="12700">
-            <a:solidFill>
-              <a:srgbClr val="16A34A"/>
-            </a:solidFill>
-            <a:prstDash val="solid"/>
-          </a:ln>
-        </p:spPr>
+          <a:ln/>
+        </p:spPr>
+      </p:sp>
+      <p:sp>
+        <p:nvSpPr>
+          <p:cNvPr id="8" name="Text 6"/>
+          <p:cNvSpPr/>
+          <p:nvPr/>
+        </p:nvSpPr>
+        <p:spPr>
+          <a:xfrm>
+            <a:off x="182880" y="2926080"/>
+            <a:ext cx="2834640" cy="2011680"/>
+          </a:xfrm>
+          <a:prstGeom prst="rect">
+            <a:avLst/>
+          </a:prstGeom>
+          <a:noFill/>
+          <a:ln/>
+        </p:spPr>
+        <p:txBody>
+          <a:bodyPr wrap="square" lIns="0" tIns="0" rIns="0" bIns="0" rtlCol="0" anchor="ctr"/>
+          <a:lstStyle/>
+          <a:p>
+            <a:pPr algn="ctr" indent="0" marL="0">
+              <a:buNone/>
+            </a:pPr>
+            <a:r>
+              <a:rPr lang="en-US" sz="1050" dirty="0">
+                <a:solidFill>
+                  <a:srgbClr val="1B4332"/>
+                </a:solidFill>
+                <a:latin typeface="Calibri" pitchFamily="34" charset="0"/>
+                <a:ea typeface="Calibri" pitchFamily="34" charset="-122"/>
+                <a:cs typeface="Calibri" pitchFamily="34" charset="-120"/>
+              </a:rPr>
+              <a:t>Each JSO must have</a:t>
+            </a:r>
+            <a:endParaRPr lang="en-US" sz="1050" dirty="0"/>
+          </a:p>
+          <a:p>
+            <a:pPr algn="ctr" indent="0" marL="0">
+              <a:buNone/>
+            </a:pPr>
+            <a:r>
+              <a:rPr lang="en-US" sz="1050" dirty="0">
+                <a:solidFill>
+                  <a:srgbClr val="1B4332"/>
+                </a:solidFill>
+                <a:latin typeface="Calibri" pitchFamily="34" charset="0"/>
+                <a:ea typeface="Calibri" pitchFamily="34" charset="-122"/>
+                <a:cs typeface="Calibri" pitchFamily="34" charset="-120"/>
+              </a:rPr>
+              <a:t>a unique JSO number</a:t>
+            </a:r>
+            <a:endParaRPr lang="en-US" sz="1050" dirty="0"/>
+          </a:p>
+          <a:p>
+            <a:pPr algn="ctr" indent="0" marL="0">
+              <a:buNone/>
+            </a:pPr>
+            <a:r>
+              <a:rPr lang="en-US" sz="1050" dirty="0">
+                <a:solidFill>
+                  <a:srgbClr val="1B4332"/>
+                </a:solidFill>
+                <a:latin typeface="Calibri" pitchFamily="34" charset="0"/>
+                <a:ea typeface="Calibri" pitchFamily="34" charset="-122"/>
+                <a:cs typeface="Calibri" pitchFamily="34" charset="-120"/>
+              </a:rPr>
+              <a:t>for traceability.</a:t>
+            </a:r>
+            <a:endParaRPr lang="en-US" sz="1050" dirty="0"/>
+          </a:p>
+          <a:p>
+            <a:pPr algn="ctr" indent="0" marL="0">
+              <a:buNone/>
+            </a:pPr>
+            <a:endParaRPr lang="en-US" sz="1050" dirty="0"/>
+          </a:p>
+          <a:p>
+            <a:pPr algn="ctr" indent="0" marL="0">
+              <a:buNone/>
+            </a:pPr>
+            <a:r>
+              <a:rPr lang="en-US" sz="1050" dirty="0">
+                <a:solidFill>
+                  <a:srgbClr val="1B4332"/>
+                </a:solidFill>
+                <a:latin typeface="Calibri" pitchFamily="34" charset="0"/>
+                <a:ea typeface="Calibri" pitchFamily="34" charset="-122"/>
+                <a:cs typeface="Calibri" pitchFamily="34" charset="-120"/>
+              </a:rPr>
+              <a:t>Photo of evidence</a:t>
+            </a:r>
+            <a:endParaRPr lang="en-US" sz="1050" dirty="0"/>
+          </a:p>
+          <a:p>
+            <a:pPr algn="ctr" indent="0" marL="0">
+              <a:buNone/>
+            </a:pPr>
+            <a:r>
+              <a:rPr lang="en-US" sz="1050" dirty="0">
+                <a:solidFill>
+                  <a:srgbClr val="1B4332"/>
+                </a:solidFill>
+                <a:latin typeface="Calibri" pitchFamily="34" charset="0"/>
+                <a:ea typeface="Calibri" pitchFamily="34" charset="-122"/>
+                <a:cs typeface="Calibri" pitchFamily="34" charset="-120"/>
+              </a:rPr>
+              <a:t>is highly recommended.</a:t>
+            </a:r>
+            <a:endParaRPr lang="en-US" sz="1050" dirty="0"/>
+          </a:p>
+        </p:txBody>
       </p:sp>
       <p:sp>
         <p:nvSpPr>
@@ -9439,24 +9390,24 @@
         </p:nvSpPr>
         <p:spPr>
           <a:xfrm>
-            <a:off x="4800600" y="1143000"/>
-            <a:ext cx="3794760" cy="320040"/>
-          </a:xfrm>
-          <a:prstGeom prst="rect">
-            <a:avLst/>
-          </a:prstGeom>
-          <a:noFill/>
-          <a:ln/>
-        </p:spPr>
-        <p:txBody>
-          <a:bodyPr wrap="square" lIns="0" tIns="0" rIns="0" bIns="0" rtlCol="0" anchor="ctr"/>
-          <a:lstStyle/>
-          <a:p>
-            <a:pPr indent="0" marL="0">
-              <a:buNone/>
-            </a:pPr>
-            <a:r>
-              <a:rPr lang="en-US" sz="1400" b="1" dirty="0">
+            <a:off x="3429000" y="201168"/>
+            <a:ext cx="5394960" cy="365760"/>
+          </a:xfrm>
+          <a:prstGeom prst="rect">
+            <a:avLst/>
+          </a:prstGeom>
+          <a:noFill/>
+          <a:ln/>
+        </p:spPr>
+        <p:txBody>
+          <a:bodyPr wrap="square" lIns="0" tIns="0" rIns="0" bIns="0" rtlCol="0" anchor="ctr"/>
+          <a:lstStyle/>
+          <a:p>
+            <a:pPr indent="0" marL="0">
+              <a:buNone/>
+            </a:pPr>
+            <a:r>
+              <a:rPr lang="en-US" sz="1600" b="1" dirty="0">
                 <a:solidFill>
                   <a:srgbClr val="1B4332"/>
                 </a:solidFill>
@@ -9464,46 +9415,66 @@
                 <a:ea typeface="Cambria" pitchFamily="34" charset="-122"/>
                 <a:cs typeface="Cambria" pitchFamily="34" charset="-120"/>
               </a:rPr>
-              <a:t>What You Enter on the Form</a:t>
-            </a:r>
-            <a:endParaRPr lang="en-US" sz="1400" dirty="0"/>
-          </a:p>
-        </p:txBody>
-      </p:sp>
-      <p:sp>
-        <p:nvSpPr>
-          <p:cNvPr id="10" name="Text 8"/>
-          <p:cNvSpPr/>
-          <p:nvPr/>
-        </p:nvSpPr>
-        <p:spPr>
-          <a:xfrm>
-            <a:off x="4800600" y="1572768"/>
-            <a:ext cx="3794760" cy="228600"/>
-          </a:xfrm>
-          <a:prstGeom prst="rect">
-            <a:avLst/>
-          </a:prstGeom>
-          <a:noFill/>
-          <a:ln/>
-        </p:spPr>
-        <p:txBody>
-          <a:bodyPr wrap="square" lIns="0" tIns="0" rIns="0" bIns="0" rtlCol="0" anchor="ctr"/>
-          <a:lstStyle/>
-          <a:p>
-            <a:pPr indent="0" marL="0">
+              <a:t>How to Submit a JSO Closure</a:t>
+            </a:r>
+            <a:endParaRPr lang="en-US" sz="1600" dirty="0"/>
+          </a:p>
+        </p:txBody>
+      </p:sp>
+      <p:sp>
+        <p:nvSpPr>
+          <p:cNvPr id="10" name="Shape 8"/>
+          <p:cNvSpPr/>
+          <p:nvPr/>
+        </p:nvSpPr>
+        <p:spPr>
+          <a:xfrm>
+            <a:off x="3429000" y="713232"/>
+            <a:ext cx="292608" cy="292608"/>
+          </a:xfrm>
+          <a:prstGeom prst="ellipse">
+            <a:avLst/>
+          </a:prstGeom>
+          <a:solidFill>
+            <a:srgbClr val="16A34A"/>
+          </a:solidFill>
+          <a:ln/>
+        </p:spPr>
+      </p:sp>
+      <p:sp>
+        <p:nvSpPr>
+          <p:cNvPr id="11" name="Text 9"/>
+          <p:cNvSpPr/>
+          <p:nvPr/>
+        </p:nvSpPr>
+        <p:spPr>
+          <a:xfrm>
+            <a:off x="3429000" y="713232"/>
+            <a:ext cx="292608" cy="292608"/>
+          </a:xfrm>
+          <a:prstGeom prst="rect">
+            <a:avLst/>
+          </a:prstGeom>
+          <a:noFill/>
+          <a:ln/>
+        </p:spPr>
+        <p:txBody>
+          <a:bodyPr wrap="square" lIns="0" tIns="0" rIns="0" bIns="0" rtlCol="0" anchor="ctr"/>
+          <a:lstStyle/>
+          <a:p>
+            <a:pPr algn="ctr" indent="0" marL="0">
               <a:buNone/>
             </a:pPr>
             <a:r>
               <a:rPr lang="en-US" sz="1100" b="1" dirty="0">
                 <a:solidFill>
-                  <a:srgbClr val="16A34A"/>
-                </a:solidFill>
-                <a:latin typeface="Calibri" pitchFamily="34" charset="0"/>
-                <a:ea typeface="Calibri" pitchFamily="34" charset="-122"/>
-                <a:cs typeface="Calibri" pitchFamily="34" charset="-120"/>
-              </a:rPr>
-              <a:t>◆  JSO Number *</a:t>
+                  <a:srgbClr val="FFFFFF"/>
+                </a:solidFill>
+                <a:latin typeface="Calibri" pitchFamily="34" charset="0"/>
+                <a:ea typeface="Calibri" pitchFamily="34" charset="-122"/>
+                <a:cs typeface="Calibri" pitchFamily="34" charset="-120"/>
+              </a:rPr>
+              <a:t>1</a:t>
             </a:r>
             <a:endParaRPr lang="en-US" sz="1100" dirty="0"/>
           </a:p>
@@ -9511,14 +9482,53 @@
       </p:sp>
       <p:sp>
         <p:nvSpPr>
-          <p:cNvPr id="11" name="Text 9"/>
-          <p:cNvSpPr/>
-          <p:nvPr/>
-        </p:nvSpPr>
-        <p:spPr>
-          <a:xfrm>
-            <a:off x="4800600" y="1810512"/>
-            <a:ext cx="3794760" cy="320040"/>
+          <p:cNvPr id="12" name="Text 10"/>
+          <p:cNvSpPr/>
+          <p:nvPr/>
+        </p:nvSpPr>
+        <p:spPr>
+          <a:xfrm>
+            <a:off x="3785616" y="685800"/>
+            <a:ext cx="5074920" cy="219456"/>
+          </a:xfrm>
+          <a:prstGeom prst="rect">
+            <a:avLst/>
+          </a:prstGeom>
+          <a:noFill/>
+          <a:ln/>
+        </p:spPr>
+        <p:txBody>
+          <a:bodyPr wrap="square" lIns="0" tIns="0" rIns="0" bIns="0" rtlCol="0" anchor="b"/>
+          <a:lstStyle/>
+          <a:p>
+            <a:pPr indent="0" marL="0">
+              <a:buNone/>
+            </a:pPr>
+            <a:r>
+              <a:rPr lang="en-US" sz="1200" b="1" dirty="0">
+                <a:solidFill>
+                  <a:srgbClr val="0F172A"/>
+                </a:solidFill>
+                <a:latin typeface="Calibri" pitchFamily="34" charset="0"/>
+                <a:ea typeface="Calibri" pitchFamily="34" charset="-122"/>
+                <a:cs typeface="Calibri" pitchFamily="34" charset="-120"/>
+              </a:rPr>
+              <a:t>Click "+ New JSO Closure"</a:t>
+            </a:r>
+            <a:endParaRPr lang="en-US" sz="1200" dirty="0"/>
+          </a:p>
+        </p:txBody>
+      </p:sp>
+      <p:sp>
+        <p:nvSpPr>
+          <p:cNvPr id="13" name="Text 11"/>
+          <p:cNvSpPr/>
+          <p:nvPr/>
+        </p:nvSpPr>
+        <p:spPr>
+          <a:xfrm>
+            <a:off x="3785616" y="914400"/>
+            <a:ext cx="5074920" cy="237744"/>
           </a:xfrm>
           <a:prstGeom prst="rect">
             <a:avLst/>
@@ -9536,13 +9546,13 @@
             <a:r>
               <a:rPr lang="en-US" sz="1000" dirty="0">
                 <a:solidFill>
-                  <a:srgbClr val="334155"/>
-                </a:solidFill>
-                <a:latin typeface="Calibri" pitchFamily="34" charset="0"/>
-                <a:ea typeface="Calibri" pitchFamily="34" charset="-122"/>
-                <a:cs typeface="Calibri" pitchFamily="34" charset="-120"/>
-              </a:rPr>
-              <a:t>The number printed on the JSO paper (e.g. JSO-2024-001). Required.</a:t>
+                  <a:srgbClr val="64748B"/>
+                </a:solidFill>
+                <a:latin typeface="Calibri" pitchFamily="34" charset="0"/>
+                <a:ea typeface="Calibri" pitchFamily="34" charset="-122"/>
+                <a:cs typeface="Calibri" pitchFamily="34" charset="-120"/>
+              </a:rPr>
+              <a:t>Top-right button on the JSO Closures list page.</a:t>
             </a:r>
             <a:endParaRPr lang="en-US" sz="1000" dirty="0"/>
           </a:p>
@@ -9550,38 +9560,78 @@
       </p:sp>
       <p:sp>
         <p:nvSpPr>
-          <p:cNvPr id="12" name="Text 10"/>
-          <p:cNvSpPr/>
-          <p:nvPr/>
-        </p:nvSpPr>
-        <p:spPr>
-          <a:xfrm>
-            <a:off x="4800600" y="2231136"/>
-            <a:ext cx="3794760" cy="228600"/>
-          </a:xfrm>
-          <a:prstGeom prst="rect">
-            <a:avLst/>
-          </a:prstGeom>
-          <a:noFill/>
-          <a:ln/>
-        </p:spPr>
-        <p:txBody>
-          <a:bodyPr wrap="square" lIns="0" tIns="0" rIns="0" bIns="0" rtlCol="0" anchor="ctr"/>
-          <a:lstStyle/>
-          <a:p>
-            <a:pPr indent="0" marL="0">
+          <p:cNvPr id="14" name="Shape 12"/>
+          <p:cNvSpPr/>
+          <p:nvPr/>
+        </p:nvSpPr>
+        <p:spPr>
+          <a:xfrm>
+            <a:off x="3529584" y="1014984"/>
+            <a:ext cx="18288" cy="301752"/>
+          </a:xfrm>
+          <a:prstGeom prst="rect">
+            <a:avLst/>
+          </a:prstGeom>
+          <a:solidFill>
+            <a:srgbClr val="E2E8F0"/>
+          </a:solidFill>
+          <a:ln/>
+        </p:spPr>
+      </p:sp>
+      <p:sp>
+        <p:nvSpPr>
+          <p:cNvPr id="15" name="Shape 13"/>
+          <p:cNvSpPr/>
+          <p:nvPr/>
+        </p:nvSpPr>
+        <p:spPr>
+          <a:xfrm>
+            <a:off x="3429000" y="1335024"/>
+            <a:ext cx="292608" cy="292608"/>
+          </a:xfrm>
+          <a:prstGeom prst="ellipse">
+            <a:avLst/>
+          </a:prstGeom>
+          <a:solidFill>
+            <a:srgbClr val="16A34A"/>
+          </a:solidFill>
+          <a:ln/>
+        </p:spPr>
+      </p:sp>
+      <p:sp>
+        <p:nvSpPr>
+          <p:cNvPr id="16" name="Text 14"/>
+          <p:cNvSpPr/>
+          <p:nvPr/>
+        </p:nvSpPr>
+        <p:spPr>
+          <a:xfrm>
+            <a:off x="3429000" y="1335024"/>
+            <a:ext cx="292608" cy="292608"/>
+          </a:xfrm>
+          <a:prstGeom prst="rect">
+            <a:avLst/>
+          </a:prstGeom>
+          <a:noFill/>
+          <a:ln/>
+        </p:spPr>
+        <p:txBody>
+          <a:bodyPr wrap="square" lIns="0" tIns="0" rIns="0" bIns="0" rtlCol="0" anchor="ctr"/>
+          <a:lstStyle/>
+          <a:p>
+            <a:pPr algn="ctr" indent="0" marL="0">
               <a:buNone/>
             </a:pPr>
             <a:r>
               <a:rPr lang="en-US" sz="1100" b="1" dirty="0">
                 <a:solidFill>
-                  <a:srgbClr val="16A34A"/>
-                </a:solidFill>
-                <a:latin typeface="Calibri" pitchFamily="34" charset="0"/>
-                <a:ea typeface="Calibri" pitchFamily="34" charset="-122"/>
-                <a:cs typeface="Calibri" pitchFamily="34" charset="-120"/>
-              </a:rPr>
-              <a:t>◆  Date</a:t>
+                  <a:srgbClr val="FFFFFF"/>
+                </a:solidFill>
+                <a:latin typeface="Calibri" pitchFamily="34" charset="0"/>
+                <a:ea typeface="Calibri" pitchFamily="34" charset="-122"/>
+                <a:cs typeface="Calibri" pitchFamily="34" charset="-120"/>
+              </a:rPr>
+              <a:t>2</a:t>
             </a:r>
             <a:endParaRPr lang="en-US" sz="1100" dirty="0"/>
           </a:p>
@@ -9589,14 +9639,53 @@
       </p:sp>
       <p:sp>
         <p:nvSpPr>
-          <p:cNvPr id="13" name="Text 11"/>
-          <p:cNvSpPr/>
-          <p:nvPr/>
-        </p:nvSpPr>
-        <p:spPr>
-          <a:xfrm>
-            <a:off x="4800600" y="2468880"/>
-            <a:ext cx="3794760" cy="320040"/>
+          <p:cNvPr id="17" name="Text 15"/>
+          <p:cNvSpPr/>
+          <p:nvPr/>
+        </p:nvSpPr>
+        <p:spPr>
+          <a:xfrm>
+            <a:off x="3785616" y="1307592"/>
+            <a:ext cx="5074920" cy="219456"/>
+          </a:xfrm>
+          <a:prstGeom prst="rect">
+            <a:avLst/>
+          </a:prstGeom>
+          <a:noFill/>
+          <a:ln/>
+        </p:spPr>
+        <p:txBody>
+          <a:bodyPr wrap="square" lIns="0" tIns="0" rIns="0" bIns="0" rtlCol="0" anchor="b"/>
+          <a:lstStyle/>
+          <a:p>
+            <a:pPr indent="0" marL="0">
+              <a:buNone/>
+            </a:pPr>
+            <a:r>
+              <a:rPr lang="en-US" sz="1200" b="1" dirty="0">
+                <a:solidFill>
+                  <a:srgbClr val="0F172A"/>
+                </a:solidFill>
+                <a:latin typeface="Calibri" pitchFamily="34" charset="0"/>
+                <a:ea typeface="Calibri" pitchFamily="34" charset="-122"/>
+                <a:cs typeface="Calibri" pitchFamily="34" charset="-120"/>
+              </a:rPr>
+              <a:t>Enter JSO Number</a:t>
+            </a:r>
+            <a:endParaRPr lang="en-US" sz="1200" dirty="0"/>
+          </a:p>
+        </p:txBody>
+      </p:sp>
+      <p:sp>
+        <p:nvSpPr>
+          <p:cNvPr id="18" name="Text 16"/>
+          <p:cNvSpPr/>
+          <p:nvPr/>
+        </p:nvSpPr>
+        <p:spPr>
+          <a:xfrm>
+            <a:off x="3785616" y="1536192"/>
+            <a:ext cx="5074920" cy="237744"/>
           </a:xfrm>
           <a:prstGeom prst="rect">
             <a:avLst/>
@@ -9614,13 +9703,13 @@
             <a:r>
               <a:rPr lang="en-US" sz="1000" dirty="0">
                 <a:solidFill>
-                  <a:srgbClr val="334155"/>
-                </a:solidFill>
-                <a:latin typeface="Calibri" pitchFamily="34" charset="0"/>
-                <a:ea typeface="Calibri" pitchFamily="34" charset="-122"/>
-                <a:cs typeface="Calibri" pitchFamily="34" charset="-120"/>
-              </a:rPr>
-              <a:t>Date the JSO was closed. Auto-fills today.</a:t>
+                  <a:srgbClr val="64748B"/>
+                </a:solidFill>
+                <a:latin typeface="Calibri" pitchFamily="34" charset="0"/>
+                <a:ea typeface="Calibri" pitchFamily="34" charset="-122"/>
+                <a:cs typeface="Calibri" pitchFamily="34" charset="-120"/>
+              </a:rPr>
+              <a:t>Type the number from the paper JSO form (e.g. JSO-2024-001). Required.</a:t>
             </a:r>
             <a:endParaRPr lang="en-US" sz="1000" dirty="0"/>
           </a:p>
@@ -9628,38 +9717,78 @@
       </p:sp>
       <p:sp>
         <p:nvSpPr>
-          <p:cNvPr id="14" name="Text 12"/>
-          <p:cNvSpPr/>
-          <p:nvPr/>
-        </p:nvSpPr>
-        <p:spPr>
-          <a:xfrm>
-            <a:off x="4800600" y="2889504"/>
-            <a:ext cx="3794760" cy="228600"/>
-          </a:xfrm>
-          <a:prstGeom prst="rect">
-            <a:avLst/>
-          </a:prstGeom>
-          <a:noFill/>
-          <a:ln/>
-        </p:spPr>
-        <p:txBody>
-          <a:bodyPr wrap="square" lIns="0" tIns="0" rIns="0" bIns="0" rtlCol="0" anchor="ctr"/>
-          <a:lstStyle/>
-          <a:p>
-            <a:pPr indent="0" marL="0">
+          <p:cNvPr id="19" name="Shape 17"/>
+          <p:cNvSpPr/>
+          <p:nvPr/>
+        </p:nvSpPr>
+        <p:spPr>
+          <a:xfrm>
+            <a:off x="3529584" y="1636776"/>
+            <a:ext cx="18288" cy="301752"/>
+          </a:xfrm>
+          <a:prstGeom prst="rect">
+            <a:avLst/>
+          </a:prstGeom>
+          <a:solidFill>
+            <a:srgbClr val="E2E8F0"/>
+          </a:solidFill>
+          <a:ln/>
+        </p:spPr>
+      </p:sp>
+      <p:sp>
+        <p:nvSpPr>
+          <p:cNvPr id="20" name="Shape 18"/>
+          <p:cNvSpPr/>
+          <p:nvPr/>
+        </p:nvSpPr>
+        <p:spPr>
+          <a:xfrm>
+            <a:off x="3429000" y="1956816"/>
+            <a:ext cx="292608" cy="292608"/>
+          </a:xfrm>
+          <a:prstGeom prst="ellipse">
+            <a:avLst/>
+          </a:prstGeom>
+          <a:solidFill>
+            <a:srgbClr val="16A34A"/>
+          </a:solidFill>
+          <a:ln/>
+        </p:spPr>
+      </p:sp>
+      <p:sp>
+        <p:nvSpPr>
+          <p:cNvPr id="21" name="Text 19"/>
+          <p:cNvSpPr/>
+          <p:nvPr/>
+        </p:nvSpPr>
+        <p:spPr>
+          <a:xfrm>
+            <a:off x="3429000" y="1956816"/>
+            <a:ext cx="292608" cy="292608"/>
+          </a:xfrm>
+          <a:prstGeom prst="rect">
+            <a:avLst/>
+          </a:prstGeom>
+          <a:noFill/>
+          <a:ln/>
+        </p:spPr>
+        <p:txBody>
+          <a:bodyPr wrap="square" lIns="0" tIns="0" rIns="0" bIns="0" rtlCol="0" anchor="ctr"/>
+          <a:lstStyle/>
+          <a:p>
+            <a:pPr algn="ctr" indent="0" marL="0">
               <a:buNone/>
             </a:pPr>
             <a:r>
               <a:rPr lang="en-US" sz="1100" b="1" dirty="0">
                 <a:solidFill>
-                  <a:srgbClr val="16A34A"/>
-                </a:solidFill>
-                <a:latin typeface="Calibri" pitchFamily="34" charset="0"/>
-                <a:ea typeface="Calibri" pitchFamily="34" charset="-122"/>
-                <a:cs typeface="Calibri" pitchFamily="34" charset="-120"/>
-              </a:rPr>
-              <a:t>◆  Location</a:t>
+                  <a:srgbClr val="FFFFFF"/>
+                </a:solidFill>
+                <a:latin typeface="Calibri" pitchFamily="34" charset="0"/>
+                <a:ea typeface="Calibri" pitchFamily="34" charset="-122"/>
+                <a:cs typeface="Calibri" pitchFamily="34" charset="-120"/>
+              </a:rPr>
+              <a:t>3</a:t>
             </a:r>
             <a:endParaRPr lang="en-US" sz="1100" dirty="0"/>
           </a:p>
@@ -9667,14 +9796,53 @@
       </p:sp>
       <p:sp>
         <p:nvSpPr>
-          <p:cNvPr id="15" name="Text 13"/>
-          <p:cNvSpPr/>
-          <p:nvPr/>
-        </p:nvSpPr>
-        <p:spPr>
-          <a:xfrm>
-            <a:off x="4800600" y="3127248"/>
-            <a:ext cx="3794760" cy="320040"/>
+          <p:cNvPr id="22" name="Text 20"/>
+          <p:cNvSpPr/>
+          <p:nvPr/>
+        </p:nvSpPr>
+        <p:spPr>
+          <a:xfrm>
+            <a:off x="3785616" y="1929384"/>
+            <a:ext cx="5074920" cy="219456"/>
+          </a:xfrm>
+          <a:prstGeom prst="rect">
+            <a:avLst/>
+          </a:prstGeom>
+          <a:noFill/>
+          <a:ln/>
+        </p:spPr>
+        <p:txBody>
+          <a:bodyPr wrap="square" lIns="0" tIns="0" rIns="0" bIns="0" rtlCol="0" anchor="b"/>
+          <a:lstStyle/>
+          <a:p>
+            <a:pPr indent="0" marL="0">
+              <a:buNone/>
+            </a:pPr>
+            <a:r>
+              <a:rPr lang="en-US" sz="1200" b="1" dirty="0">
+                <a:solidFill>
+                  <a:srgbClr val="0F172A"/>
+                </a:solidFill>
+                <a:latin typeface="Calibri" pitchFamily="34" charset="0"/>
+                <a:ea typeface="Calibri" pitchFamily="34" charset="-122"/>
+                <a:cs typeface="Calibri" pitchFamily="34" charset="-120"/>
+              </a:rPr>
+              <a:t>Set Date</a:t>
+            </a:r>
+            <a:endParaRPr lang="en-US" sz="1200" dirty="0"/>
+          </a:p>
+        </p:txBody>
+      </p:sp>
+      <p:sp>
+        <p:nvSpPr>
+          <p:cNvPr id="23" name="Text 21"/>
+          <p:cNvSpPr/>
+          <p:nvPr/>
+        </p:nvSpPr>
+        <p:spPr>
+          <a:xfrm>
+            <a:off x="3785616" y="2157984"/>
+            <a:ext cx="5074920" cy="237744"/>
           </a:xfrm>
           <a:prstGeom prst="rect">
             <a:avLst/>
@@ -9692,13 +9860,13 @@
             <a:r>
               <a:rPr lang="en-US" sz="1000" dirty="0">
                 <a:solidFill>
-                  <a:srgbClr val="334155"/>
-                </a:solidFill>
-                <a:latin typeface="Calibri" pitchFamily="34" charset="0"/>
-                <a:ea typeface="Calibri" pitchFamily="34" charset="-122"/>
-                <a:cs typeface="Calibri" pitchFamily="34" charset="-120"/>
-              </a:rPr>
-              <a:t>Site area where the JSO was performed.</a:t>
+                  <a:srgbClr val="64748B"/>
+                </a:solidFill>
+                <a:latin typeface="Calibri" pitchFamily="34" charset="0"/>
+                <a:ea typeface="Calibri" pitchFamily="34" charset="-122"/>
+                <a:cs typeface="Calibri" pitchFamily="34" charset="-120"/>
+              </a:rPr>
+              <a:t>Auto-fills with today's date. Change it if the JSO was closed on a different day.</a:t>
             </a:r>
             <a:endParaRPr lang="en-US" sz="1000" dirty="0"/>
           </a:p>
@@ -9706,38 +9874,78 @@
       </p:sp>
       <p:sp>
         <p:nvSpPr>
-          <p:cNvPr id="16" name="Text 14"/>
-          <p:cNvSpPr/>
-          <p:nvPr/>
-        </p:nvSpPr>
-        <p:spPr>
-          <a:xfrm>
-            <a:off x="4800600" y="3547872"/>
-            <a:ext cx="3794760" cy="228600"/>
-          </a:xfrm>
-          <a:prstGeom prst="rect">
-            <a:avLst/>
-          </a:prstGeom>
-          <a:noFill/>
-          <a:ln/>
-        </p:spPr>
-        <p:txBody>
-          <a:bodyPr wrap="square" lIns="0" tIns="0" rIns="0" bIns="0" rtlCol="0" anchor="ctr"/>
-          <a:lstStyle/>
-          <a:p>
-            <a:pPr indent="0" marL="0">
+          <p:cNvPr id="24" name="Shape 22"/>
+          <p:cNvSpPr/>
+          <p:nvPr/>
+        </p:nvSpPr>
+        <p:spPr>
+          <a:xfrm>
+            <a:off x="3529584" y="2258568"/>
+            <a:ext cx="18288" cy="301752"/>
+          </a:xfrm>
+          <a:prstGeom prst="rect">
+            <a:avLst/>
+          </a:prstGeom>
+          <a:solidFill>
+            <a:srgbClr val="E2E8F0"/>
+          </a:solidFill>
+          <a:ln/>
+        </p:spPr>
+      </p:sp>
+      <p:sp>
+        <p:nvSpPr>
+          <p:cNvPr id="25" name="Shape 23"/>
+          <p:cNvSpPr/>
+          <p:nvPr/>
+        </p:nvSpPr>
+        <p:spPr>
+          <a:xfrm>
+            <a:off x="3429000" y="2578608"/>
+            <a:ext cx="292608" cy="292608"/>
+          </a:xfrm>
+          <a:prstGeom prst="ellipse">
+            <a:avLst/>
+          </a:prstGeom>
+          <a:solidFill>
+            <a:srgbClr val="16A34A"/>
+          </a:solidFill>
+          <a:ln/>
+        </p:spPr>
+      </p:sp>
+      <p:sp>
+        <p:nvSpPr>
+          <p:cNvPr id="26" name="Text 24"/>
+          <p:cNvSpPr/>
+          <p:nvPr/>
+        </p:nvSpPr>
+        <p:spPr>
+          <a:xfrm>
+            <a:off x="3429000" y="2578608"/>
+            <a:ext cx="292608" cy="292608"/>
+          </a:xfrm>
+          <a:prstGeom prst="rect">
+            <a:avLst/>
+          </a:prstGeom>
+          <a:noFill/>
+          <a:ln/>
+        </p:spPr>
+        <p:txBody>
+          <a:bodyPr wrap="square" lIns="0" tIns="0" rIns="0" bIns="0" rtlCol="0" anchor="ctr"/>
+          <a:lstStyle/>
+          <a:p>
+            <a:pPr algn="ctr" indent="0" marL="0">
               <a:buNone/>
             </a:pPr>
             <a:r>
               <a:rPr lang="en-US" sz="1100" b="1" dirty="0">
                 <a:solidFill>
-                  <a:srgbClr val="16A34A"/>
-                </a:solidFill>
-                <a:latin typeface="Calibri" pitchFamily="34" charset="0"/>
-                <a:ea typeface="Calibri" pitchFamily="34" charset="-122"/>
-                <a:cs typeface="Calibri" pitchFamily="34" charset="-120"/>
-              </a:rPr>
-              <a:t>◆  Action Taken</a:t>
+                  <a:srgbClr val="FFFFFF"/>
+                </a:solidFill>
+                <a:latin typeface="Calibri" pitchFamily="34" charset="0"/>
+                <a:ea typeface="Calibri" pitchFamily="34" charset="-122"/>
+                <a:cs typeface="Calibri" pitchFamily="34" charset="-120"/>
+              </a:rPr>
+              <a:t>4</a:t>
             </a:r>
             <a:endParaRPr lang="en-US" sz="1100" dirty="0"/>
           </a:p>
@@ -9745,14 +9953,53 @@
       </p:sp>
       <p:sp>
         <p:nvSpPr>
-          <p:cNvPr id="17" name="Text 15"/>
-          <p:cNvSpPr/>
-          <p:nvPr/>
-        </p:nvSpPr>
-        <p:spPr>
-          <a:xfrm>
-            <a:off x="4800600" y="3785616"/>
-            <a:ext cx="3794760" cy="320040"/>
+          <p:cNvPr id="27" name="Text 25"/>
+          <p:cNvSpPr/>
+          <p:nvPr/>
+        </p:nvSpPr>
+        <p:spPr>
+          <a:xfrm>
+            <a:off x="3785616" y="2551176"/>
+            <a:ext cx="5074920" cy="219456"/>
+          </a:xfrm>
+          <a:prstGeom prst="rect">
+            <a:avLst/>
+          </a:prstGeom>
+          <a:noFill/>
+          <a:ln/>
+        </p:spPr>
+        <p:txBody>
+          <a:bodyPr wrap="square" lIns="0" tIns="0" rIns="0" bIns="0" rtlCol="0" anchor="b"/>
+          <a:lstStyle/>
+          <a:p>
+            <a:pPr indent="0" marL="0">
+              <a:buNone/>
+            </a:pPr>
+            <a:r>
+              <a:rPr lang="en-US" sz="1200" b="1" dirty="0">
+                <a:solidFill>
+                  <a:srgbClr val="0F172A"/>
+                </a:solidFill>
+                <a:latin typeface="Calibri" pitchFamily="34" charset="0"/>
+                <a:ea typeface="Calibri" pitchFamily="34" charset="-122"/>
+                <a:cs typeface="Calibri" pitchFamily="34" charset="-120"/>
+              </a:rPr>
+              <a:t>Enter Location</a:t>
+            </a:r>
+            <a:endParaRPr lang="en-US" sz="1200" dirty="0"/>
+          </a:p>
+        </p:txBody>
+      </p:sp>
+      <p:sp>
+        <p:nvSpPr>
+          <p:cNvPr id="28" name="Text 26"/>
+          <p:cNvSpPr/>
+          <p:nvPr/>
+        </p:nvSpPr>
+        <p:spPr>
+          <a:xfrm>
+            <a:off x="3785616" y="2779776"/>
+            <a:ext cx="5074920" cy="237744"/>
           </a:xfrm>
           <a:prstGeom prst="rect">
             <a:avLst/>
@@ -9770,13 +10017,13 @@
             <a:r>
               <a:rPr lang="en-US" sz="1000" dirty="0">
                 <a:solidFill>
-                  <a:srgbClr val="334155"/>
-                </a:solidFill>
-                <a:latin typeface="Calibri" pitchFamily="34" charset="0"/>
-                <a:ea typeface="Calibri" pitchFamily="34" charset="-122"/>
-                <a:cs typeface="Calibri" pitchFamily="34" charset="-120"/>
-              </a:rPr>
-              <a:t>Describe what was done to close the hazard.</a:t>
+                  <a:srgbClr val="64748B"/>
+                </a:solidFill>
+                <a:latin typeface="Calibri" pitchFamily="34" charset="0"/>
+                <a:ea typeface="Calibri" pitchFamily="34" charset="-122"/>
+                <a:cs typeface="Calibri" pitchFamily="34" charset="-120"/>
+              </a:rPr>
+              <a:t>Type the site area where the JSO was carried out. Suggestions appear as you type.</a:t>
             </a:r>
             <a:endParaRPr lang="en-US" sz="1000" dirty="0"/>
           </a:p>
@@ -9784,38 +10031,78 @@
       </p:sp>
       <p:sp>
         <p:nvSpPr>
-          <p:cNvPr id="18" name="Text 16"/>
-          <p:cNvSpPr/>
-          <p:nvPr/>
-        </p:nvSpPr>
-        <p:spPr>
-          <a:xfrm>
-            <a:off x="4800600" y="4206240"/>
-            <a:ext cx="3794760" cy="228600"/>
-          </a:xfrm>
-          <a:prstGeom prst="rect">
-            <a:avLst/>
-          </a:prstGeom>
-          <a:noFill/>
-          <a:ln/>
-        </p:spPr>
-        <p:txBody>
-          <a:bodyPr wrap="square" lIns="0" tIns="0" rIns="0" bIns="0" rtlCol="0" anchor="ctr"/>
-          <a:lstStyle/>
-          <a:p>
-            <a:pPr indent="0" marL="0">
+          <p:cNvPr id="29" name="Shape 27"/>
+          <p:cNvSpPr/>
+          <p:nvPr/>
+        </p:nvSpPr>
+        <p:spPr>
+          <a:xfrm>
+            <a:off x="3529584" y="2880360"/>
+            <a:ext cx="18288" cy="301752"/>
+          </a:xfrm>
+          <a:prstGeom prst="rect">
+            <a:avLst/>
+          </a:prstGeom>
+          <a:solidFill>
+            <a:srgbClr val="E2E8F0"/>
+          </a:solidFill>
+          <a:ln/>
+        </p:spPr>
+      </p:sp>
+      <p:sp>
+        <p:nvSpPr>
+          <p:cNvPr id="30" name="Shape 28"/>
+          <p:cNvSpPr/>
+          <p:nvPr/>
+        </p:nvSpPr>
+        <p:spPr>
+          <a:xfrm>
+            <a:off x="3429000" y="3200400"/>
+            <a:ext cx="292608" cy="292608"/>
+          </a:xfrm>
+          <a:prstGeom prst="ellipse">
+            <a:avLst/>
+          </a:prstGeom>
+          <a:solidFill>
+            <a:srgbClr val="16A34A"/>
+          </a:solidFill>
+          <a:ln/>
+        </p:spPr>
+      </p:sp>
+      <p:sp>
+        <p:nvSpPr>
+          <p:cNvPr id="31" name="Text 29"/>
+          <p:cNvSpPr/>
+          <p:nvPr/>
+        </p:nvSpPr>
+        <p:spPr>
+          <a:xfrm>
+            <a:off x="3429000" y="3200400"/>
+            <a:ext cx="292608" cy="292608"/>
+          </a:xfrm>
+          <a:prstGeom prst="rect">
+            <a:avLst/>
+          </a:prstGeom>
+          <a:noFill/>
+          <a:ln/>
+        </p:spPr>
+        <p:txBody>
+          <a:bodyPr wrap="square" lIns="0" tIns="0" rIns="0" bIns="0" rtlCol="0" anchor="ctr"/>
+          <a:lstStyle/>
+          <a:p>
+            <a:pPr algn="ctr" indent="0" marL="0">
               <a:buNone/>
             </a:pPr>
             <a:r>
               <a:rPr lang="en-US" sz="1100" b="1" dirty="0">
                 <a:solidFill>
-                  <a:srgbClr val="16A34A"/>
-                </a:solidFill>
-                <a:latin typeface="Calibri" pitchFamily="34" charset="0"/>
-                <a:ea typeface="Calibri" pitchFamily="34" charset="-122"/>
-                <a:cs typeface="Calibri" pitchFamily="34" charset="-120"/>
-              </a:rPr>
-              <a:t>◆  Evidence Photo</a:t>
+                  <a:srgbClr val="FFFFFF"/>
+                </a:solidFill>
+                <a:latin typeface="Calibri" pitchFamily="34" charset="0"/>
+                <a:ea typeface="Calibri" pitchFamily="34" charset="-122"/>
+                <a:cs typeface="Calibri" pitchFamily="34" charset="-120"/>
+              </a:rPr>
+              <a:t>5</a:t>
             </a:r>
             <a:endParaRPr lang="en-US" sz="1100" dirty="0"/>
           </a:p>
@@ -9823,14 +10110,53 @@
       </p:sp>
       <p:sp>
         <p:nvSpPr>
-          <p:cNvPr id="19" name="Text 17"/>
-          <p:cNvSpPr/>
-          <p:nvPr/>
-        </p:nvSpPr>
-        <p:spPr>
-          <a:xfrm>
-            <a:off x="4800600" y="4443984"/>
-            <a:ext cx="3794760" cy="320040"/>
+          <p:cNvPr id="32" name="Text 30"/>
+          <p:cNvSpPr/>
+          <p:nvPr/>
+        </p:nvSpPr>
+        <p:spPr>
+          <a:xfrm>
+            <a:off x="3785616" y="3172968"/>
+            <a:ext cx="5074920" cy="219456"/>
+          </a:xfrm>
+          <a:prstGeom prst="rect">
+            <a:avLst/>
+          </a:prstGeom>
+          <a:noFill/>
+          <a:ln/>
+        </p:spPr>
+        <p:txBody>
+          <a:bodyPr wrap="square" lIns="0" tIns="0" rIns="0" bIns="0" rtlCol="0" anchor="b"/>
+          <a:lstStyle/>
+          <a:p>
+            <a:pPr indent="0" marL="0">
+              <a:buNone/>
+            </a:pPr>
+            <a:r>
+              <a:rPr lang="en-US" sz="1200" b="1" dirty="0">
+                <a:solidFill>
+                  <a:srgbClr val="0F172A"/>
+                </a:solidFill>
+                <a:latin typeface="Calibri" pitchFamily="34" charset="0"/>
+                <a:ea typeface="Calibri" pitchFamily="34" charset="-122"/>
+                <a:cs typeface="Calibri" pitchFamily="34" charset="-120"/>
+              </a:rPr>
+              <a:t>Describe Action Taken</a:t>
+            </a:r>
+            <a:endParaRPr lang="en-US" sz="1200" dirty="0"/>
+          </a:p>
+        </p:txBody>
+      </p:sp>
+      <p:sp>
+        <p:nvSpPr>
+          <p:cNvPr id="33" name="Text 31"/>
+          <p:cNvSpPr/>
+          <p:nvPr/>
+        </p:nvSpPr>
+        <p:spPr>
+          <a:xfrm>
+            <a:off x="3785616" y="3401568"/>
+            <a:ext cx="5074920" cy="237744"/>
           </a:xfrm>
           <a:prstGeom prst="rect">
             <a:avLst/>
@@ -9848,13 +10174,327 @@
             <a:r>
               <a:rPr lang="en-US" sz="1000" dirty="0">
                 <a:solidFill>
-                  <a:srgbClr val="334155"/>
-                </a:solidFill>
-                <a:latin typeface="Calibri" pitchFamily="34" charset="0"/>
-                <a:ea typeface="Calibri" pitchFamily="34" charset="-122"/>
-                <a:cs typeface="Calibri" pitchFamily="34" charset="-120"/>
-              </a:rPr>
-              <a:t>Upload a photo proving the issue is resolved.</a:t>
+                  <a:srgbClr val="64748B"/>
+                </a:solidFill>
+                <a:latin typeface="Calibri" pitchFamily="34" charset="0"/>
+                <a:ea typeface="Calibri" pitchFamily="34" charset="-122"/>
+                <a:cs typeface="Calibri" pitchFamily="34" charset="-120"/>
+              </a:rPr>
+              <a:t>Write clearly what was done to resolve the identified hazard.</a:t>
+            </a:r>
+            <a:endParaRPr lang="en-US" sz="1000" dirty="0"/>
+          </a:p>
+        </p:txBody>
+      </p:sp>
+      <p:sp>
+        <p:nvSpPr>
+          <p:cNvPr id="34" name="Shape 32"/>
+          <p:cNvSpPr/>
+          <p:nvPr/>
+        </p:nvSpPr>
+        <p:spPr>
+          <a:xfrm>
+            <a:off x="3529584" y="3502152"/>
+            <a:ext cx="18288" cy="301752"/>
+          </a:xfrm>
+          <a:prstGeom prst="rect">
+            <a:avLst/>
+          </a:prstGeom>
+          <a:solidFill>
+            <a:srgbClr val="E2E8F0"/>
+          </a:solidFill>
+          <a:ln/>
+        </p:spPr>
+      </p:sp>
+      <p:sp>
+        <p:nvSpPr>
+          <p:cNvPr id="35" name="Shape 33"/>
+          <p:cNvSpPr/>
+          <p:nvPr/>
+        </p:nvSpPr>
+        <p:spPr>
+          <a:xfrm>
+            <a:off x="3429000" y="3822192"/>
+            <a:ext cx="292608" cy="292608"/>
+          </a:xfrm>
+          <a:prstGeom prst="ellipse">
+            <a:avLst/>
+          </a:prstGeom>
+          <a:solidFill>
+            <a:srgbClr val="16A34A"/>
+          </a:solidFill>
+          <a:ln/>
+        </p:spPr>
+      </p:sp>
+      <p:sp>
+        <p:nvSpPr>
+          <p:cNvPr id="36" name="Text 34"/>
+          <p:cNvSpPr/>
+          <p:nvPr/>
+        </p:nvSpPr>
+        <p:spPr>
+          <a:xfrm>
+            <a:off x="3429000" y="3822192"/>
+            <a:ext cx="292608" cy="292608"/>
+          </a:xfrm>
+          <a:prstGeom prst="rect">
+            <a:avLst/>
+          </a:prstGeom>
+          <a:noFill/>
+          <a:ln/>
+        </p:spPr>
+        <p:txBody>
+          <a:bodyPr wrap="square" lIns="0" tIns="0" rIns="0" bIns="0" rtlCol="0" anchor="ctr"/>
+          <a:lstStyle/>
+          <a:p>
+            <a:pPr algn="ctr" indent="0" marL="0">
+              <a:buNone/>
+            </a:pPr>
+            <a:r>
+              <a:rPr lang="en-US" sz="1100" b="1" dirty="0">
+                <a:solidFill>
+                  <a:srgbClr val="FFFFFF"/>
+                </a:solidFill>
+                <a:latin typeface="Calibri" pitchFamily="34" charset="0"/>
+                <a:ea typeface="Calibri" pitchFamily="34" charset="-122"/>
+                <a:cs typeface="Calibri" pitchFamily="34" charset="-120"/>
+              </a:rPr>
+              <a:t>6</a:t>
+            </a:r>
+            <a:endParaRPr lang="en-US" sz="1100" dirty="0"/>
+          </a:p>
+        </p:txBody>
+      </p:sp>
+      <p:sp>
+        <p:nvSpPr>
+          <p:cNvPr id="37" name="Text 35"/>
+          <p:cNvSpPr/>
+          <p:nvPr/>
+        </p:nvSpPr>
+        <p:spPr>
+          <a:xfrm>
+            <a:off x="3785616" y="3794760"/>
+            <a:ext cx="5074920" cy="219456"/>
+          </a:xfrm>
+          <a:prstGeom prst="rect">
+            <a:avLst/>
+          </a:prstGeom>
+          <a:noFill/>
+          <a:ln/>
+        </p:spPr>
+        <p:txBody>
+          <a:bodyPr wrap="square" lIns="0" tIns="0" rIns="0" bIns="0" rtlCol="0" anchor="b"/>
+          <a:lstStyle/>
+          <a:p>
+            <a:pPr indent="0" marL="0">
+              <a:buNone/>
+            </a:pPr>
+            <a:r>
+              <a:rPr lang="en-US" sz="1200" b="1" dirty="0">
+                <a:solidFill>
+                  <a:srgbClr val="0F172A"/>
+                </a:solidFill>
+                <a:latin typeface="Calibri" pitchFamily="34" charset="0"/>
+                <a:ea typeface="Calibri" pitchFamily="34" charset="-122"/>
+                <a:cs typeface="Calibri" pitchFamily="34" charset="-120"/>
+              </a:rPr>
+              <a:t>Upload Evidence Photo</a:t>
+            </a:r>
+            <a:endParaRPr lang="en-US" sz="1200" dirty="0"/>
+          </a:p>
+        </p:txBody>
+      </p:sp>
+      <p:sp>
+        <p:nvSpPr>
+          <p:cNvPr id="38" name="Text 36"/>
+          <p:cNvSpPr/>
+          <p:nvPr/>
+        </p:nvSpPr>
+        <p:spPr>
+          <a:xfrm>
+            <a:off x="3785616" y="4023360"/>
+            <a:ext cx="5074920" cy="237744"/>
+          </a:xfrm>
+          <a:prstGeom prst="rect">
+            <a:avLst/>
+          </a:prstGeom>
+          <a:noFill/>
+          <a:ln/>
+        </p:spPr>
+        <p:txBody>
+          <a:bodyPr wrap="square" lIns="0" tIns="0" rIns="0" bIns="0" rtlCol="0" anchor="t"/>
+          <a:lstStyle/>
+          <a:p>
+            <a:pPr indent="0" marL="0">
+              <a:buNone/>
+            </a:pPr>
+            <a:r>
+              <a:rPr lang="en-US" sz="1000" dirty="0">
+                <a:solidFill>
+                  <a:srgbClr val="64748B"/>
+                </a:solidFill>
+                <a:latin typeface="Calibri" pitchFamily="34" charset="0"/>
+                <a:ea typeface="Calibri" pitchFamily="34" charset="-122"/>
+                <a:cs typeface="Calibri" pitchFamily="34" charset="-120"/>
+              </a:rPr>
+              <a:t>Take a photo showing the corrected situation and upload it as proof.</a:t>
+            </a:r>
+            <a:endParaRPr lang="en-US" sz="1000" dirty="0"/>
+          </a:p>
+        </p:txBody>
+      </p:sp>
+      <p:sp>
+        <p:nvSpPr>
+          <p:cNvPr id="39" name="Shape 37"/>
+          <p:cNvSpPr/>
+          <p:nvPr/>
+        </p:nvSpPr>
+        <p:spPr>
+          <a:xfrm>
+            <a:off x="3529584" y="4123944"/>
+            <a:ext cx="18288" cy="301752"/>
+          </a:xfrm>
+          <a:prstGeom prst="rect">
+            <a:avLst/>
+          </a:prstGeom>
+          <a:solidFill>
+            <a:srgbClr val="E2E8F0"/>
+          </a:solidFill>
+          <a:ln/>
+        </p:spPr>
+      </p:sp>
+      <p:sp>
+        <p:nvSpPr>
+          <p:cNvPr id="40" name="Shape 38"/>
+          <p:cNvSpPr/>
+          <p:nvPr/>
+        </p:nvSpPr>
+        <p:spPr>
+          <a:xfrm>
+            <a:off x="3429000" y="4443984"/>
+            <a:ext cx="292608" cy="292608"/>
+          </a:xfrm>
+          <a:prstGeom prst="ellipse">
+            <a:avLst/>
+          </a:prstGeom>
+          <a:solidFill>
+            <a:srgbClr val="16A34A"/>
+          </a:solidFill>
+          <a:ln/>
+        </p:spPr>
+      </p:sp>
+      <p:sp>
+        <p:nvSpPr>
+          <p:cNvPr id="41" name="Text 39"/>
+          <p:cNvSpPr/>
+          <p:nvPr/>
+        </p:nvSpPr>
+        <p:spPr>
+          <a:xfrm>
+            <a:off x="3429000" y="4443984"/>
+            <a:ext cx="292608" cy="292608"/>
+          </a:xfrm>
+          <a:prstGeom prst="rect">
+            <a:avLst/>
+          </a:prstGeom>
+          <a:noFill/>
+          <a:ln/>
+        </p:spPr>
+        <p:txBody>
+          <a:bodyPr wrap="square" lIns="0" tIns="0" rIns="0" bIns="0" rtlCol="0" anchor="ctr"/>
+          <a:lstStyle/>
+          <a:p>
+            <a:pPr algn="ctr" indent="0" marL="0">
+              <a:buNone/>
+            </a:pPr>
+            <a:r>
+              <a:rPr lang="en-US" sz="1100" b="1" dirty="0">
+                <a:solidFill>
+                  <a:srgbClr val="FFFFFF"/>
+                </a:solidFill>
+                <a:latin typeface="Calibri" pitchFamily="34" charset="0"/>
+                <a:ea typeface="Calibri" pitchFamily="34" charset="-122"/>
+                <a:cs typeface="Calibri" pitchFamily="34" charset="-120"/>
+              </a:rPr>
+              <a:t>7</a:t>
+            </a:r>
+            <a:endParaRPr lang="en-US" sz="1100" dirty="0"/>
+          </a:p>
+        </p:txBody>
+      </p:sp>
+      <p:sp>
+        <p:nvSpPr>
+          <p:cNvPr id="42" name="Text 40"/>
+          <p:cNvSpPr/>
+          <p:nvPr/>
+        </p:nvSpPr>
+        <p:spPr>
+          <a:xfrm>
+            <a:off x="3785616" y="4416552"/>
+            <a:ext cx="5074920" cy="219456"/>
+          </a:xfrm>
+          <a:prstGeom prst="rect">
+            <a:avLst/>
+          </a:prstGeom>
+          <a:noFill/>
+          <a:ln/>
+        </p:spPr>
+        <p:txBody>
+          <a:bodyPr wrap="square" lIns="0" tIns="0" rIns="0" bIns="0" rtlCol="0" anchor="b"/>
+          <a:lstStyle/>
+          <a:p>
+            <a:pPr indent="0" marL="0">
+              <a:buNone/>
+            </a:pPr>
+            <a:r>
+              <a:rPr lang="en-US" sz="1200" b="1" dirty="0">
+                <a:solidFill>
+                  <a:srgbClr val="0F172A"/>
+                </a:solidFill>
+                <a:latin typeface="Calibri" pitchFamily="34" charset="0"/>
+                <a:ea typeface="Calibri" pitchFamily="34" charset="-122"/>
+                <a:cs typeface="Calibri" pitchFamily="34" charset="-120"/>
+              </a:rPr>
+              <a:t>Click "Save"</a:t>
+            </a:r>
+            <a:endParaRPr lang="en-US" sz="1200" dirty="0"/>
+          </a:p>
+        </p:txBody>
+      </p:sp>
+      <p:sp>
+        <p:nvSpPr>
+          <p:cNvPr id="43" name="Text 41"/>
+          <p:cNvSpPr/>
+          <p:nvPr/>
+        </p:nvSpPr>
+        <p:spPr>
+          <a:xfrm>
+            <a:off x="3785616" y="4645152"/>
+            <a:ext cx="5074920" cy="237744"/>
+          </a:xfrm>
+          <a:prstGeom prst="rect">
+            <a:avLst/>
+          </a:prstGeom>
+          <a:noFill/>
+          <a:ln/>
+        </p:spPr>
+        <p:txBody>
+          <a:bodyPr wrap="square" lIns="0" tIns="0" rIns="0" bIns="0" rtlCol="0" anchor="t"/>
+          <a:lstStyle/>
+          <a:p>
+            <a:pPr indent="0" marL="0">
+              <a:buNone/>
+            </a:pPr>
+            <a:r>
+              <a:rPr lang="en-US" sz="1000" dirty="0">
+                <a:solidFill>
+                  <a:srgbClr val="64748B"/>
+                </a:solidFill>
+                <a:latin typeface="Calibri" pitchFamily="34" charset="0"/>
+                <a:ea typeface="Calibri" pitchFamily="34" charset="-122"/>
+                <a:cs typeface="Calibri" pitchFamily="34" charset="-120"/>
+              </a:rPr>
+              <a:t>The record is saved and appears in your JSO Closures list.</a:t>
             </a:r>
             <a:endParaRPr lang="en-US" sz="1000" dirty="0"/>
           </a:p>

</xml_diff>